<commit_message>
fix in recur slides and other small changes
</commit_message>
<xml_diff>
--- a/slides/02-3-Kruskals.pptx
+++ b/slides/02-3-Kruskals.pptx
@@ -220,7 +220,7 @@
           <a:p>
             <a:fld id="{C5B45307-6ED4-B142-BD64-10F739779302}" type="datetimeFigureOut">
               <a:rPr lang="en-US" smtClean="0"/>
-              <a:t>8/11/25</a:t>
+              <a:t>9/16/25</a:t>
             </a:fld>
             <a:endParaRPr lang="en-US"/>
           </a:p>
@@ -4769,7 +4769,7 @@
           <a:p>
             <a:fld id="{A3195221-79EA-9D42-9404-49B04A8A98FE}" type="datetime1">
               <a:rPr lang="en-US" smtClean="0"/>
-              <a:t>8/11/25</a:t>
+              <a:t>9/16/25</a:t>
             </a:fld>
             <a:endParaRPr lang="en-US"/>
           </a:p>
@@ -5036,7 +5036,7 @@
           <a:p>
             <a:fld id="{CF5CAC72-1054-5349-B819-EC5816012906}" type="datetime1">
               <a:rPr lang="en-US" smtClean="0"/>
-              <a:t>8/11/25</a:t>
+              <a:t>9/16/25</a:t>
             </a:fld>
             <a:endParaRPr lang="en-US"/>
           </a:p>
@@ -5232,7 +5232,7 @@
           <a:p>
             <a:fld id="{B2AEA80C-9698-6B49-AF03-BA3E91654186}" type="datetime1">
               <a:rPr lang="en-US" smtClean="0"/>
-              <a:t>8/11/25</a:t>
+              <a:t>9/16/25</a:t>
             </a:fld>
             <a:endParaRPr lang="en-US"/>
           </a:p>
@@ -5495,7 +5495,7 @@
           <a:p>
             <a:fld id="{EA7D610D-B844-3A4B-9828-A3C0146A0045}" type="datetime1">
               <a:rPr lang="en-US" smtClean="0"/>
-              <a:t>8/11/25</a:t>
+              <a:t>9/16/25</a:t>
             </a:fld>
             <a:endParaRPr lang="en-US"/>
           </a:p>
@@ -5929,7 +5929,7 @@
           <a:p>
             <a:fld id="{31993245-F9CB-F248-B658-090812430620}" type="datetime1">
               <a:rPr lang="en-US" smtClean="0"/>
-              <a:t>8/11/25</a:t>
+              <a:t>9/16/25</a:t>
             </a:fld>
             <a:endParaRPr lang="en-US"/>
           </a:p>
@@ -6475,7 +6475,7 @@
           <a:p>
             <a:fld id="{D57A3EA2-D4AF-154F-B9E4-E56A24E64A69}" type="datetime1">
               <a:rPr lang="en-US" smtClean="0"/>
-              <a:t>8/11/25</a:t>
+              <a:t>9/16/25</a:t>
             </a:fld>
             <a:endParaRPr lang="en-US"/>
           </a:p>
@@ -7195,7 +7195,7 @@
           <a:p>
             <a:fld id="{CA89C3C0-B8DA-2947-9D8B-FC36B7912149}" type="datetime1">
               <a:rPr lang="en-US" smtClean="0"/>
-              <a:t>8/11/25</a:t>
+              <a:t>9/16/25</a:t>
             </a:fld>
             <a:endParaRPr lang="en-US"/>
           </a:p>
@@ -7365,7 +7365,7 @@
           <a:p>
             <a:fld id="{9C6875AB-3A7F-F044-91E5-B05AA8DCDB7D}" type="datetime1">
               <a:rPr lang="en-US" smtClean="0"/>
-              <a:t>8/11/25</a:t>
+              <a:t>9/16/25</a:t>
             </a:fld>
             <a:endParaRPr lang="en-US"/>
           </a:p>
@@ -7545,7 +7545,7 @@
           <a:p>
             <a:fld id="{CBF5F35A-0699-3649-A13E-ECA0919D0BEE}" type="datetime1">
               <a:rPr lang="en-US" smtClean="0"/>
-              <a:t>8/11/25</a:t>
+              <a:t>9/16/25</a:t>
             </a:fld>
             <a:endParaRPr lang="en-US"/>
           </a:p>
@@ -7715,7 +7715,7 @@
           <a:p>
             <a:fld id="{B1AE6046-C0D1-204B-BBFD-D30F3D59F0C6}" type="datetime1">
               <a:rPr lang="en-US" smtClean="0"/>
-              <a:t>8/11/25</a:t>
+              <a:t>9/16/25</a:t>
             </a:fld>
             <a:endParaRPr lang="en-US"/>
           </a:p>
@@ -7965,7 +7965,7 @@
           <a:p>
             <a:fld id="{98FCD73B-A524-6648-B3C8-00881046033F}" type="datetime1">
               <a:rPr lang="en-US" smtClean="0"/>
-              <a:t>8/11/25</a:t>
+              <a:t>9/16/25</a:t>
             </a:fld>
             <a:endParaRPr lang="en-US"/>
           </a:p>
@@ -8197,7 +8197,7 @@
           <a:p>
             <a:fld id="{708FB6FC-D15B-9B4D-BAF7-B376DC2D833C}" type="datetime1">
               <a:rPr lang="en-US" smtClean="0"/>
-              <a:t>8/11/25</a:t>
+              <a:t>9/16/25</a:t>
             </a:fld>
             <a:endParaRPr lang="en-US"/>
           </a:p>
@@ -8583,7 +8583,7 @@
           <a:p>
             <a:fld id="{1F0F0D92-C3CC-CF46-AB4F-19D71E204EF6}" type="datetime1">
               <a:rPr lang="en-US" smtClean="0"/>
-              <a:t>8/11/25</a:t>
+              <a:t>9/16/25</a:t>
             </a:fld>
             <a:endParaRPr lang="en-US"/>
           </a:p>
@@ -8706,7 +8706,7 @@
           <a:p>
             <a:fld id="{C4EC1D0C-6CF0-1E41-AA89-F332E723F52A}" type="datetime1">
               <a:rPr lang="en-US" smtClean="0"/>
-              <a:t>8/11/25</a:t>
+              <a:t>9/16/25</a:t>
             </a:fld>
             <a:endParaRPr lang="en-US"/>
           </a:p>
@@ -8801,7 +8801,7 @@
           <a:p>
             <a:fld id="{6D029F41-0600-3A49-A738-B6A30278C01E}" type="datetime1">
               <a:rPr lang="en-US" smtClean="0"/>
-              <a:t>8/11/25</a:t>
+              <a:t>9/16/25</a:t>
             </a:fld>
             <a:endParaRPr lang="en-US"/>
           </a:p>
@@ -9050,7 +9050,7 @@
           <a:p>
             <a:fld id="{DD8BB7CF-3211-0C4C-BF98-05F94ED81F47}" type="datetime1">
               <a:rPr lang="en-US" smtClean="0"/>
-              <a:t>8/11/25</a:t>
+              <a:t>9/16/25</a:t>
             </a:fld>
             <a:endParaRPr lang="en-US"/>
           </a:p>
@@ -9335,7 +9335,7 @@
           <a:p>
             <a:fld id="{5966A86B-713D-3F41-BD30-E73F286D8C94}" type="datetime1">
               <a:rPr lang="en-US" smtClean="0"/>
-              <a:t>8/11/25</a:t>
+              <a:t>9/16/25</a:t>
             </a:fld>
             <a:endParaRPr lang="en-US"/>
           </a:p>
@@ -12402,7 +12402,7 @@
           <a:p>
             <a:fld id="{7F39ED2F-F966-714C-AA81-E993DB6D6BBA}" type="datetime1">
               <a:rPr lang="en-US" smtClean="0"/>
-              <a:t>8/11/25</a:t>
+              <a:t>9/16/25</a:t>
             </a:fld>
             <a:endParaRPr lang="en-US"/>
           </a:p>
@@ -12942,7 +12942,7 @@
         </p:nvSpPr>
         <p:spPr>
           <a:xfrm>
-            <a:off x="1223322" y="1023936"/>
+            <a:off x="643903" y="1023936"/>
             <a:ext cx="6302072" cy="5486400"/>
           </a:xfrm>
           <a:solidFill>
@@ -13516,8 +13516,8 @@
             </p:nvSpPr>
             <p:spPr>
               <a:xfrm>
-                <a:off x="7609491" y="2709923"/>
-                <a:ext cx="4183116" cy="2114425"/>
+                <a:off x="7097917" y="2709923"/>
+                <a:ext cx="4694690" cy="1837491"/>
               </a:xfrm>
               <a:prstGeom prst="rect">
                 <a:avLst/>
@@ -13610,10 +13610,28 @@
                             <m:t>𝐸</m:t>
                           </m:r>
                           <m:r>
-                            <a:rPr lang="en-US" sz="2100" i="1">
+                            <a:rPr lang="en-US" sz="2100" b="0" i="1" smtClean="0">
                               <a:latin typeface="Cambria Math" panose="02040503050406030204" pitchFamily="18" charset="0"/>
                             </a:rPr>
-                            <m:t>∗2</m:t>
+                            <m:t>⋅(</m:t>
+                          </m:r>
+                          <m:r>
+                            <a:rPr lang="en-US" sz="2100" b="0" i="1" smtClean="0">
+                              <a:latin typeface="Cambria Math" panose="02040503050406030204" pitchFamily="18" charset="0"/>
+                            </a:rPr>
+                            <m:t>𝑙𝑜𝑔𝐸</m:t>
+                          </m:r>
+                          <m:r>
+                            <a:rPr lang="en-US" sz="2100" b="0" i="1" smtClean="0">
+                              <a:latin typeface="Cambria Math" panose="02040503050406030204" pitchFamily="18" charset="0"/>
+                            </a:rPr>
+                            <m:t>+</m:t>
+                          </m:r>
+                          <m:r>
+                            <a:rPr lang="en-US" sz="2100" b="0" i="1" smtClean="0">
+                              <a:latin typeface="Cambria Math" panose="02040503050406030204" pitchFamily="18" charset="0"/>
+                            </a:rPr>
+                            <m:t>2</m:t>
                           </m:r>
                           <m:r>
                             <a:rPr lang="en-US" sz="2100" i="1">
@@ -13639,6 +13657,12 @@
                             </m:e>
                           </m:d>
                           <m:r>
+                            <a:rPr lang="en-US" sz="2100" b="0" i="1" smtClean="0">
+                              <a:latin typeface="Cambria Math" panose="02040503050406030204" pitchFamily="18" charset="0"/>
+                            </a:rPr>
+                            <m:t>)</m:t>
+                          </m:r>
+                          <m:r>
                             <a:rPr lang="en-US" sz="2100" i="1">
                               <a:latin typeface="Cambria Math" panose="02040503050406030204" pitchFamily="18" charset="0"/>
                             </a:rPr>
@@ -13651,10 +13675,10 @@
                             <m:t>𝑉</m:t>
                           </m:r>
                           <m:r>
-                            <a:rPr lang="en-US" sz="2100" i="1">
+                            <a:rPr lang="en-US" sz="2100" b="0" i="1" smtClean="0">
                               <a:latin typeface="Cambria Math" panose="02040503050406030204" pitchFamily="18" charset="0"/>
                             </a:rPr>
-                            <m:t>∗</m:t>
+                            <m:t>⋅</m:t>
                           </m:r>
                           <m:r>
                             <a:rPr lang="en-US" sz="2100" i="1">
@@ -13685,9 +13709,11 @@
                     </m:oMath>
                   </m:oMathPara>
                 </a14:m>
-                <a:endParaRPr lang="en-US" sz="2100" dirty="0"/>
-              </a:p>
-              <a:p>
+                <a:br>
+                  <a:rPr lang="en-US" sz="2100" i="1" dirty="0">
+                    <a:latin typeface="Cambria Math" panose="02040503050406030204" pitchFamily="18" charset="0"/>
+                  </a:rPr>
+                </a:br>
                 <a:endParaRPr lang="en-US" dirty="0"/>
               </a:p>
             </p:txBody>
@@ -13710,8 +13736,8 @@
             </p:nvSpPr>
             <p:spPr>
               <a:xfrm>
-                <a:off x="7609491" y="2709923"/>
-                <a:ext cx="4183116" cy="2114425"/>
+                <a:off x="7097917" y="2709923"/>
+                <a:ext cx="4694690" cy="1837491"/>
               </a:xfrm>
               <a:prstGeom prst="rect">
                 <a:avLst/>
@@ -13719,7 +13745,7 @@
               <a:blipFill>
                 <a:blip r:embed="rId3"/>
                 <a:stretch>
-                  <a:fillRect t="-3593" r="-1818"/>
+                  <a:fillRect t="-4110" b="-3425"/>
                 </a:stretch>
               </a:blipFill>
             </p:spPr>
@@ -16323,11 +16349,7 @@
                   <a:schemeClr val="accent2"/>
                 </a:solidFill>
               </a:rPr>
-              <a:t>)    </a:t>
-            </a:r>
-            <a:r>
-              <a:rPr lang="en-US" dirty="0"/>
-              <a:t> </a:t>
+              <a:t>)   , </a:t>
             </a:r>
             <a:r>
               <a:rPr lang="en-US" dirty="0">
@@ -21231,8 +21253,8 @@
           </a:p>
         </p:txBody>
       </p:sp>
-      <mc:AlternateContent xmlns:mc="http://schemas.openxmlformats.org/markup-compatibility/2006">
-        <mc:Choice xmlns:a14="http://schemas.microsoft.com/office/drawing/2010/main" Requires="a14">
+      <mc:AlternateContent xmlns:mc="http://schemas.openxmlformats.org/markup-compatibility/2006" xmlns:a14="http://schemas.microsoft.com/office/drawing/2010/main">
+        <mc:Choice Requires="a14">
           <p:sp>
             <p:nvSpPr>
               <p:cNvPr id="81924" name="Rectangle 3"/>
@@ -21410,7 +21432,7 @@
                           <a:rPr lang="en-US" b="0" i="1" smtClean="0">
                             <a:latin typeface="Cambria Math" panose="02040503050406030204" pitchFamily="18" charset="0"/>
                           </a:rPr>
-                          <m:t>∗</m:t>
+                          <m:t>⋅</m:t>
                         </m:r>
                         <m:func>
                           <m:funcPr>
@@ -21445,7 +21467,7 @@
                                   <a:rPr lang="en-US" b="0" i="1" smtClean="0">
                                     <a:latin typeface="Cambria Math" panose="02040503050406030204" pitchFamily="18" charset="0"/>
                                   </a:rPr>
-                                  <m:t>𝑉</m:t>
+                                  <m:t>𝐸</m:t>
                                 </m:r>
                               </m:e>
                             </m:d>
@@ -21461,13 +21483,13 @@
                           <a:rPr lang="en-US" b="0" i="1" smtClean="0">
                             <a:latin typeface="Cambria Math" panose="02040503050406030204" pitchFamily="18" charset="0"/>
                           </a:rPr>
-                          <m:t>𝐸</m:t>
+                          <m:t>𝑉</m:t>
                         </m:r>
                         <m:r>
                           <a:rPr lang="en-US" b="0" i="1" smtClean="0">
                             <a:latin typeface="Cambria Math" panose="02040503050406030204" pitchFamily="18" charset="0"/>
                           </a:rPr>
-                          <m:t>∗1</m:t>
+                          <m:t>⋅1</m:t>
                         </m:r>
                       </m:e>
                     </m:d>
@@ -21559,7 +21581,7 @@
             </p:txBody>
           </p:sp>
         </mc:Choice>
-        <mc:Fallback>
+        <mc:Fallback xmlns="">
           <p:sp>
             <p:nvSpPr>
               <p:cNvPr id="81924" name="Rectangle 3"/>
@@ -21569,7 +21591,7 @@
               <p:nvPr>
                 <p:ph sz="quarter" idx="1"/>
                 <p:custDataLst>
-                  <p:tags r:id="rId2"/>
+                  <p:tags r:id="rId4"/>
                 </p:custDataLst>
               </p:nvPr>
             </p:nvSpPr>
@@ -21579,7 +21601,7 @@
                 <a:ext cx="9905999" cy="3541714"/>
               </a:xfrm>
               <a:blipFill>
-                <a:blip r:embed="rId4"/>
+                <a:blip r:embed="rId5"/>
                 <a:stretch>
                   <a:fillRect l="-1280" t="-1071"/>
                 </a:stretch>

</xml_diff>